<commit_message>
docs: update presentation deck
</commit_message>
<xml_diff>
--- a/presentations/Enterprise-Safe Copilot Orchestration for Azure Landing Zone Governance.pptx
+++ b/presentations/Enterprise-Safe Copilot Orchestration for Azure Landing Zone Governance.pptx
@@ -7726,7 +7726,7 @@
         </p:nvSpPr>
         <p:spPr>
           <a:xfrm>
-            <a:off x="868680" y="2212848"/>
+            <a:off x="868680" y="2157984"/>
             <a:ext cx="4792828" cy="1252728"/>
           </a:xfrm>
           <a:prstGeom prst="rect">
@@ -7851,6 +7851,48 @@
                 <a:cs typeface="Segoe UI" pitchFamily="34" charset="-120"/>
               </a:rPr>
               <a:t>Re‑runnable assessments with deterministic delta tracking</a:t>
+            </a:r>
+          </a:p>
+          <a:p>
+            <a:pPr marL="285750" indent="-285750">
+              <a:lnSpc>
+                <a:spcPct val="115000"/>
+              </a:lnSpc>
+              <a:spcAft>
+                <a:spcPts val="400"/>
+              </a:spcAft>
+              <a:buFont typeface="Arial" panose="020B0604020202020204" pitchFamily="34" charset="0"/>
+              <a:buChar char="•"/>
+            </a:pPr>
+            <a:r>
+              <a:rPr lang="en-US" sz="1250" dirty="0">
+                <a:solidFill>
+                  <a:srgbClr val="2B2B2B"/>
+                </a:solidFill>
+                <a:latin typeface="Segoe UI" pitchFamily="34" charset="0"/>
+                <a:cs typeface="Segoe UI" pitchFamily="34" charset="-120"/>
+              </a:rPr>
+              <a:t>Reduces delivery time, </a:t>
+            </a:r>
+            <a:r>
+              <a:rPr lang="en-US" sz="1250">
+                <a:solidFill>
+                  <a:srgbClr val="2B2B2B"/>
+                </a:solidFill>
+                <a:latin typeface="Segoe UI" pitchFamily="34" charset="0"/>
+                <a:cs typeface="Segoe UI" pitchFamily="34" charset="-120"/>
+              </a:rPr>
+              <a:t>lowers risk, </a:t>
+            </a:r>
+            <a:r>
+              <a:rPr lang="en-US" sz="1250" dirty="0">
+                <a:solidFill>
+                  <a:srgbClr val="2B2B2B"/>
+                </a:solidFill>
+                <a:latin typeface="Segoe UI" pitchFamily="34" charset="0"/>
+                <a:cs typeface="Segoe UI" pitchFamily="34" charset="-120"/>
+              </a:rPr>
+              <a:t>and enables repeatability</a:t>
             </a:r>
             <a:endParaRPr lang="en-US" sz="1250" dirty="0"/>
           </a:p>

</xml_diff>